<commit_message>
docs(sop): key visuals Colab (ardilla + wordmark) en PPTX V0–V3
Membrete y portada con lockup squirrel-cacao + logo nominativo CACAO COLAB.

Co-authored-by: Amaury Amed <amauryamed-svg@users.noreply.github.com>
</commit_message>
<xml_diff>
--- a/docs/sop/querencia/SOP-B0-V0-FEAR5-La-Querencia.pptx
+++ b/docs/sop/querencia/SOP-B0-V0-FEAR5-La-Querencia.pptx
@@ -3187,16 +3187,64 @@
           </a:p>
         </p:txBody>
       </p:sp>
-      <p:sp>
-        <p:nvSpPr>
-          <p:cNvPr id="4" name="TextBox 3"/>
+      <p:pic>
+        <p:nvPicPr>
+          <p:cNvPr id="4" name="Picture 3" descr="lockup-yellow.png"/>
+          <p:cNvPicPr>
+            <a:picLocks noChangeAspect="1"/>
+          </p:cNvPicPr>
+          <p:nvPr/>
+        </p:nvPicPr>
+        <p:blipFill>
+          <a:blip r:embed="rId2"/>
+          <a:stretch>
+            <a:fillRect/>
+          </a:stretch>
+        </p:blipFill>
+        <p:spPr>
+          <a:xfrm>
+            <a:off x="594360" y="411480"/>
+            <a:ext cx="5129784" cy="777240"/>
+          </a:xfrm>
+          <a:prstGeom prst="rect">
+            <a:avLst/>
+          </a:prstGeom>
+        </p:spPr>
+      </p:pic>
+      <p:pic>
+        <p:nvPicPr>
+          <p:cNvPr id="5" name="Picture 4" descr="squirrel-cacao.png"/>
+          <p:cNvPicPr>
+            <a:picLocks noChangeAspect="1"/>
+          </p:cNvPicPr>
+          <p:nvPr/>
+        </p:nvPicPr>
+        <p:blipFill>
+          <a:blip r:embed="rId3"/>
+          <a:stretch>
+            <a:fillRect/>
+          </a:stretch>
+        </p:blipFill>
+        <p:spPr>
+          <a:xfrm>
+            <a:off x="9326880" y="1417320"/>
+            <a:ext cx="3468189" cy="3291840"/>
+          </a:xfrm>
+          <a:prstGeom prst="rect">
+            <a:avLst/>
+          </a:prstGeom>
+        </p:spPr>
+      </p:pic>
+      <p:sp>
+        <p:nvSpPr>
+          <p:cNvPr id="6" name="TextBox 5"/>
           <p:cNvSpPr txBox="1"/>
           <p:nvPr/>
         </p:nvSpPr>
         <p:spPr>
           <a:xfrm>
-            <a:off x="640080" y="502920"/>
-            <a:ext cx="10058400" cy="320040"/>
+            <a:off x="640080" y="1371600"/>
+            <a:ext cx="8229600" cy="365760"/>
           </a:xfrm>
           <a:prstGeom prst="rect">
             <a:avLst/>
@@ -3211,27 +3259,27 @@
           <a:p>
             <a:pPr algn="l"/>
             <a:r>
-              <a:rPr sz="1400" b="1">
+              <a:rPr sz="1600" b="1">
                 <a:solidFill>
                   <a:srgbClr val="F2C830"/>
                 </a:solidFill>
                 <a:latin typeface="Calibri"/>
               </a:rPr>
-              <a:t>CACAO COLAB  ×  LA QUERENCIA</a:t>
-            </a:r>
-          </a:p>
-        </p:txBody>
-      </p:sp>
-      <p:sp>
-        <p:nvSpPr>
-          <p:cNvPr id="5" name="TextBox 4"/>
+              <a:t>×  LA QUERENCIA</a:t>
+            </a:r>
+          </a:p>
+        </p:txBody>
+      </p:sp>
+      <p:sp>
+        <p:nvSpPr>
+          <p:cNvPr id="7" name="TextBox 6"/>
           <p:cNvSpPr txBox="1"/>
           <p:nvPr/>
         </p:nvSpPr>
         <p:spPr>
           <a:xfrm>
-            <a:off x="640080" y="1234440"/>
-            <a:ext cx="10972800" cy="914400"/>
+            <a:off x="640080" y="1874519"/>
+            <a:ext cx="8686800" cy="914400"/>
           </a:xfrm>
           <a:prstGeom prst="rect">
             <a:avLst/>
@@ -3246,7 +3294,7 @@
           <a:p>
             <a:pPr algn="l"/>
             <a:r>
-              <a:rPr sz="4000" b="1">
+              <a:rPr sz="3600" b="1">
                 <a:solidFill>
                   <a:srgbClr val="F7F1EE"/>
                 </a:solidFill>
@@ -3259,14 +3307,14 @@
       </p:sp>
       <p:sp>
         <p:nvSpPr>
-          <p:cNvPr id="6" name="TextBox 5"/>
+          <p:cNvPr id="8" name="TextBox 7"/>
           <p:cNvSpPr txBox="1"/>
           <p:nvPr/>
         </p:nvSpPr>
         <p:spPr>
           <a:xfrm>
-            <a:off x="640080" y="2240280"/>
-            <a:ext cx="10972800" cy="502920"/>
+            <a:off x="640080" y="2788920"/>
+            <a:ext cx="8229600" cy="457200"/>
           </a:xfrm>
           <a:prstGeom prst="rect">
             <a:avLst/>
@@ -3281,7 +3329,7 @@
           <a:p>
             <a:pPr algn="l"/>
             <a:r>
-              <a:rPr sz="2200" b="0">
+              <a:rPr sz="1800" b="0">
                 <a:solidFill>
                   <a:srgbClr val="F2C830"/>
                 </a:solidFill>
@@ -3294,14 +3342,14 @@
       </p:sp>
       <p:sp>
         <p:nvSpPr>
-          <p:cNvPr id="7" name="TextBox 6"/>
+          <p:cNvPr id="9" name="TextBox 8"/>
           <p:cNvSpPr txBox="1"/>
           <p:nvPr/>
         </p:nvSpPr>
         <p:spPr>
           <a:xfrm>
-            <a:off x="640080" y="3017520"/>
-            <a:ext cx="10515600" cy="1463040"/>
+            <a:off x="640080" y="3383280"/>
+            <a:ext cx="8229600" cy="1463040"/>
           </a:xfrm>
           <a:prstGeom prst="rect">
             <a:avLst/>
@@ -3316,7 +3364,7 @@
           <a:p>
             <a:pPr algn="l"/>
             <a:r>
-              <a:rPr sz="1700" b="0">
+              <a:rPr sz="1600" b="0">
                 <a:solidFill>
                   <a:srgbClr val="F7F1EE"/>
                 </a:solidFill>
@@ -3332,7 +3380,7 @@
       </p:sp>
       <p:sp>
         <p:nvSpPr>
-          <p:cNvPr id="8" name="TextBox 7"/>
+          <p:cNvPr id="10" name="TextBox 9"/>
           <p:cNvSpPr txBox="1"/>
           <p:nvPr/>
         </p:nvSpPr>
@@ -3367,7 +3415,7 @@
       </p:sp>
       <p:sp>
         <p:nvSpPr>
-          <p:cNvPr id="9" name="TextBox 8"/>
+          <p:cNvPr id="11" name="TextBox 10"/>
           <p:cNvSpPr txBox="1"/>
           <p:nvPr/>
         </p:nvSpPr>
@@ -3427,7 +3475,7 @@
         <p:spPr>
           <a:xfrm>
             <a:off x="0" y="0"/>
-            <a:ext cx="12191695" cy="658368"/>
+            <a:ext cx="12191695" cy="777240"/>
           </a:xfrm>
           <a:prstGeom prst="rect">
             <a:avLst/>
@@ -3469,7 +3517,7 @@
         </p:nvSpPr>
         <p:spPr>
           <a:xfrm>
-            <a:off x="0" y="658368"/>
+            <a:off x="0" y="777240"/>
             <a:ext cx="12191695" cy="73152"/>
           </a:xfrm>
           <a:prstGeom prst="rect">
@@ -3504,16 +3552,40 @@
           </a:p>
         </p:txBody>
       </p:sp>
-      <p:sp>
-        <p:nvSpPr>
-          <p:cNvPr id="4" name="TextBox 3"/>
+      <p:pic>
+        <p:nvPicPr>
+          <p:cNvPr id="4" name="Picture 3" descr="lockup-yellow.png"/>
+          <p:cNvPicPr>
+            <a:picLocks noChangeAspect="1"/>
+          </p:cNvPicPr>
+          <p:nvPr/>
+        </p:nvPicPr>
+        <p:blipFill>
+          <a:blip r:embed="rId2"/>
+          <a:stretch>
+            <a:fillRect/>
+          </a:stretch>
+        </p:blipFill>
+        <p:spPr>
+          <a:xfrm>
+            <a:off x="365760" y="109728"/>
+            <a:ext cx="3741725" cy="566928"/>
+          </a:xfrm>
+          <a:prstGeom prst="rect">
+            <a:avLst/>
+          </a:prstGeom>
+        </p:spPr>
+      </p:pic>
+      <p:sp>
+        <p:nvSpPr>
+          <p:cNvPr id="5" name="TextBox 4"/>
           <p:cNvSpPr txBox="1"/>
           <p:nvPr/>
         </p:nvSpPr>
         <p:spPr>
           <a:xfrm>
-            <a:off x="502920" y="128016"/>
-            <a:ext cx="5486400" cy="411480"/>
+            <a:off x="6766560" y="256032"/>
+            <a:ext cx="5029200" cy="365760"/>
           </a:xfrm>
           <a:prstGeom prst="rect">
             <a:avLst/>
@@ -3526,41 +3598,6 @@
           </a:bodyPr>
           <a:lstStyle/>
           <a:p>
-            <a:pPr algn="l"/>
-            <a:r>
-              <a:rPr sz="2000" b="1">
-                <a:solidFill>
-                  <a:srgbClr val="F2C830"/>
-                </a:solidFill>
-                <a:latin typeface="Georgia"/>
-              </a:rPr>
-              <a:t>CACAO COLAB</a:t>
-            </a:r>
-          </a:p>
-        </p:txBody>
-      </p:sp>
-      <p:sp>
-        <p:nvSpPr>
-          <p:cNvPr id="5" name="TextBox 4"/>
-          <p:cNvSpPr txBox="1"/>
-          <p:nvPr/>
-        </p:nvSpPr>
-        <p:spPr>
-          <a:xfrm>
-            <a:off x="6217920" y="164592"/>
-            <a:ext cx="5394960" cy="365760"/>
-          </a:xfrm>
-          <a:prstGeom prst="rect">
-            <a:avLst/>
-          </a:prstGeom>
-          <a:noFill/>
-        </p:spPr>
-        <p:txBody>
-          <a:bodyPr wrap="square">
-            <a:spAutoFit/>
-          </a:bodyPr>
-          <a:lstStyle/>
-          <a:p>
             <a:pPr algn="r"/>
             <a:r>
               <a:rPr sz="1200" b="0">
@@ -3582,7 +3619,7 @@
         </p:nvSpPr>
         <p:spPr>
           <a:xfrm>
-            <a:off x="502920" y="960120"/>
+            <a:off x="502920" y="1051560"/>
             <a:ext cx="10972800" cy="411480"/>
           </a:xfrm>
           <a:prstGeom prst="rect">
@@ -3827,16 +3864,40 @@
           </a:p>
         </p:txBody>
       </p:sp>
-      <p:sp>
-        <p:nvSpPr>
-          <p:cNvPr id="10" name="TextBox 9"/>
+      <p:pic>
+        <p:nvPicPr>
+          <p:cNvPr id="10" name="Picture 9" descr="squirrel-cacao.png"/>
+          <p:cNvPicPr>
+            <a:picLocks noChangeAspect="1"/>
+          </p:cNvPicPr>
+          <p:nvPr/>
+        </p:nvPicPr>
+        <p:blipFill>
+          <a:blip r:embed="rId3"/>
+          <a:stretch>
+            <a:fillRect/>
+          </a:stretch>
+        </p:blipFill>
+        <p:spPr>
+          <a:xfrm>
+            <a:off x="411480" y="6382512"/>
+            <a:ext cx="308283" cy="292608"/>
+          </a:xfrm>
+          <a:prstGeom prst="rect">
+            <a:avLst/>
+          </a:prstGeom>
+        </p:spPr>
+      </p:pic>
+      <p:sp>
+        <p:nvSpPr>
+          <p:cNvPr id="11" name="TextBox 10"/>
           <p:cNvSpPr txBox="1"/>
           <p:nvPr/>
         </p:nvSpPr>
         <p:spPr>
           <a:xfrm>
-            <a:off x="502920" y="6446520"/>
-            <a:ext cx="8229600" cy="274320"/>
+            <a:off x="822960" y="6446520"/>
+            <a:ext cx="7772400" cy="274320"/>
           </a:xfrm>
           <a:prstGeom prst="rect">
             <a:avLst/>
@@ -3857,14 +3918,14 @@
                 </a:solidFill>
                 <a:latin typeface="Calibri"/>
               </a:rPr>
-              <a:t>La Querencia · FEAR 5 · V0→V3  ·  cacaocolab.org</a:t>
-            </a:r>
-          </a:p>
-        </p:txBody>
-      </p:sp>
-      <p:sp>
-        <p:nvSpPr>
-          <p:cNvPr id="11" name="TextBox 10"/>
+              <a:t>Cacao Colab  ·  La Querencia · FEAR 5 · V0→V3  ·  cacaocolab.org</a:t>
+            </a:r>
+          </a:p>
+        </p:txBody>
+      </p:sp>
+      <p:sp>
+        <p:nvSpPr>
+          <p:cNvPr id="12" name="TextBox 11"/>
           <p:cNvSpPr txBox="1"/>
           <p:nvPr/>
         </p:nvSpPr>
@@ -3924,7 +3985,7 @@
         <p:spPr>
           <a:xfrm>
             <a:off x="0" y="0"/>
-            <a:ext cx="12191695" cy="658368"/>
+            <a:ext cx="12191695" cy="777240"/>
           </a:xfrm>
           <a:prstGeom prst="rect">
             <a:avLst/>
@@ -3966,7 +4027,7 @@
         </p:nvSpPr>
         <p:spPr>
           <a:xfrm>
-            <a:off x="0" y="658368"/>
+            <a:off x="0" y="777240"/>
             <a:ext cx="12191695" cy="73152"/>
           </a:xfrm>
           <a:prstGeom prst="rect">
@@ -4001,16 +4062,40 @@
           </a:p>
         </p:txBody>
       </p:sp>
-      <p:sp>
-        <p:nvSpPr>
-          <p:cNvPr id="4" name="TextBox 3"/>
+      <p:pic>
+        <p:nvPicPr>
+          <p:cNvPr id="4" name="Picture 3" descr="lockup-yellow.png"/>
+          <p:cNvPicPr>
+            <a:picLocks noChangeAspect="1"/>
+          </p:cNvPicPr>
+          <p:nvPr/>
+        </p:nvPicPr>
+        <p:blipFill>
+          <a:blip r:embed="rId2"/>
+          <a:stretch>
+            <a:fillRect/>
+          </a:stretch>
+        </p:blipFill>
+        <p:spPr>
+          <a:xfrm>
+            <a:off x="365760" y="109728"/>
+            <a:ext cx="3741725" cy="566928"/>
+          </a:xfrm>
+          <a:prstGeom prst="rect">
+            <a:avLst/>
+          </a:prstGeom>
+        </p:spPr>
+      </p:pic>
+      <p:sp>
+        <p:nvSpPr>
+          <p:cNvPr id="5" name="TextBox 4"/>
           <p:cNvSpPr txBox="1"/>
           <p:nvPr/>
         </p:nvSpPr>
         <p:spPr>
           <a:xfrm>
-            <a:off x="502920" y="128016"/>
-            <a:ext cx="5486400" cy="411480"/>
+            <a:off x="6766560" y="256032"/>
+            <a:ext cx="5029200" cy="365760"/>
           </a:xfrm>
           <a:prstGeom prst="rect">
             <a:avLst/>
@@ -4023,41 +4108,6 @@
           </a:bodyPr>
           <a:lstStyle/>
           <a:p>
-            <a:pPr algn="l"/>
-            <a:r>
-              <a:rPr sz="2000" b="1">
-                <a:solidFill>
-                  <a:srgbClr val="F2C830"/>
-                </a:solidFill>
-                <a:latin typeface="Georgia"/>
-              </a:rPr>
-              <a:t>CACAO COLAB</a:t>
-            </a:r>
-          </a:p>
-        </p:txBody>
-      </p:sp>
-      <p:sp>
-        <p:nvSpPr>
-          <p:cNvPr id="5" name="TextBox 4"/>
-          <p:cNvSpPr txBox="1"/>
-          <p:nvPr/>
-        </p:nvSpPr>
-        <p:spPr>
-          <a:xfrm>
-            <a:off x="6217920" y="164592"/>
-            <a:ext cx="5394960" cy="365760"/>
-          </a:xfrm>
-          <a:prstGeom prst="rect">
-            <a:avLst/>
-          </a:prstGeom>
-          <a:noFill/>
-        </p:spPr>
-        <p:txBody>
-          <a:bodyPr wrap="square">
-            <a:spAutoFit/>
-          </a:bodyPr>
-          <a:lstStyle/>
-          <a:p>
             <a:pPr algn="r"/>
             <a:r>
               <a:rPr sz="1200" b="0">
@@ -4079,7 +4129,7 @@
         </p:nvSpPr>
         <p:spPr>
           <a:xfrm>
-            <a:off x="502920" y="960120"/>
+            <a:off x="502920" y="1051560"/>
             <a:ext cx="10972800" cy="411480"/>
           </a:xfrm>
           <a:prstGeom prst="rect">
@@ -4324,16 +4374,40 @@
           </a:p>
         </p:txBody>
       </p:sp>
-      <p:sp>
-        <p:nvSpPr>
-          <p:cNvPr id="10" name="TextBox 9"/>
+      <p:pic>
+        <p:nvPicPr>
+          <p:cNvPr id="10" name="Picture 9" descr="squirrel-cacao.png"/>
+          <p:cNvPicPr>
+            <a:picLocks noChangeAspect="1"/>
+          </p:cNvPicPr>
+          <p:nvPr/>
+        </p:nvPicPr>
+        <p:blipFill>
+          <a:blip r:embed="rId3"/>
+          <a:stretch>
+            <a:fillRect/>
+          </a:stretch>
+        </p:blipFill>
+        <p:spPr>
+          <a:xfrm>
+            <a:off x="411480" y="6382512"/>
+            <a:ext cx="308283" cy="292608"/>
+          </a:xfrm>
+          <a:prstGeom prst="rect">
+            <a:avLst/>
+          </a:prstGeom>
+        </p:spPr>
+      </p:pic>
+      <p:sp>
+        <p:nvSpPr>
+          <p:cNvPr id="11" name="TextBox 10"/>
           <p:cNvSpPr txBox="1"/>
           <p:nvPr/>
         </p:nvSpPr>
         <p:spPr>
           <a:xfrm>
-            <a:off x="502920" y="6446520"/>
-            <a:ext cx="8229600" cy="274320"/>
+            <a:off x="822960" y="6446520"/>
+            <a:ext cx="7772400" cy="274320"/>
           </a:xfrm>
           <a:prstGeom prst="rect">
             <a:avLst/>
@@ -4354,14 +4428,14 @@
                 </a:solidFill>
                 <a:latin typeface="Calibri"/>
               </a:rPr>
-              <a:t>La Querencia · FEAR 5 · V0→V3  ·  cacaocolab.org</a:t>
-            </a:r>
-          </a:p>
-        </p:txBody>
-      </p:sp>
-      <p:sp>
-        <p:nvSpPr>
-          <p:cNvPr id="11" name="TextBox 10"/>
+              <a:t>Cacao Colab  ·  La Querencia · FEAR 5 · V0→V3  ·  cacaocolab.org</a:t>
+            </a:r>
+          </a:p>
+        </p:txBody>
+      </p:sp>
+      <p:sp>
+        <p:nvSpPr>
+          <p:cNvPr id="12" name="TextBox 11"/>
           <p:cNvSpPr txBox="1"/>
           <p:nvPr/>
         </p:nvSpPr>
@@ -4421,7 +4495,7 @@
         <p:spPr>
           <a:xfrm>
             <a:off x="0" y="0"/>
-            <a:ext cx="12191695" cy="658368"/>
+            <a:ext cx="12191695" cy="777240"/>
           </a:xfrm>
           <a:prstGeom prst="rect">
             <a:avLst/>
@@ -4463,7 +4537,7 @@
         </p:nvSpPr>
         <p:spPr>
           <a:xfrm>
-            <a:off x="0" y="658368"/>
+            <a:off x="0" y="777240"/>
             <a:ext cx="12191695" cy="73152"/>
           </a:xfrm>
           <a:prstGeom prst="rect">
@@ -4498,16 +4572,40 @@
           </a:p>
         </p:txBody>
       </p:sp>
-      <p:sp>
-        <p:nvSpPr>
-          <p:cNvPr id="4" name="TextBox 3"/>
+      <p:pic>
+        <p:nvPicPr>
+          <p:cNvPr id="4" name="Picture 3" descr="lockup-yellow.png"/>
+          <p:cNvPicPr>
+            <a:picLocks noChangeAspect="1"/>
+          </p:cNvPicPr>
+          <p:nvPr/>
+        </p:nvPicPr>
+        <p:blipFill>
+          <a:blip r:embed="rId2"/>
+          <a:stretch>
+            <a:fillRect/>
+          </a:stretch>
+        </p:blipFill>
+        <p:spPr>
+          <a:xfrm>
+            <a:off x="365760" y="109728"/>
+            <a:ext cx="3741725" cy="566928"/>
+          </a:xfrm>
+          <a:prstGeom prst="rect">
+            <a:avLst/>
+          </a:prstGeom>
+        </p:spPr>
+      </p:pic>
+      <p:sp>
+        <p:nvSpPr>
+          <p:cNvPr id="5" name="TextBox 4"/>
           <p:cNvSpPr txBox="1"/>
           <p:nvPr/>
         </p:nvSpPr>
         <p:spPr>
           <a:xfrm>
-            <a:off x="502920" y="128016"/>
-            <a:ext cx="5486400" cy="411480"/>
+            <a:off x="6766560" y="256032"/>
+            <a:ext cx="5029200" cy="365760"/>
           </a:xfrm>
           <a:prstGeom prst="rect">
             <a:avLst/>
@@ -4520,41 +4618,6 @@
           </a:bodyPr>
           <a:lstStyle/>
           <a:p>
-            <a:pPr algn="l"/>
-            <a:r>
-              <a:rPr sz="2000" b="1">
-                <a:solidFill>
-                  <a:srgbClr val="F2C830"/>
-                </a:solidFill>
-                <a:latin typeface="Georgia"/>
-              </a:rPr>
-              <a:t>CACAO COLAB</a:t>
-            </a:r>
-          </a:p>
-        </p:txBody>
-      </p:sp>
-      <p:sp>
-        <p:nvSpPr>
-          <p:cNvPr id="5" name="TextBox 4"/>
-          <p:cNvSpPr txBox="1"/>
-          <p:nvPr/>
-        </p:nvSpPr>
-        <p:spPr>
-          <a:xfrm>
-            <a:off x="6217920" y="164592"/>
-            <a:ext cx="5394960" cy="365760"/>
-          </a:xfrm>
-          <a:prstGeom prst="rect">
-            <a:avLst/>
-          </a:prstGeom>
-          <a:noFill/>
-        </p:spPr>
-        <p:txBody>
-          <a:bodyPr wrap="square">
-            <a:spAutoFit/>
-          </a:bodyPr>
-          <a:lstStyle/>
-          <a:p>
             <a:pPr algn="r"/>
             <a:r>
               <a:rPr sz="1200" b="0">
@@ -4576,7 +4639,7 @@
         </p:nvSpPr>
         <p:spPr>
           <a:xfrm>
-            <a:off x="502920" y="960120"/>
+            <a:off x="502920" y="1051560"/>
             <a:ext cx="10972800" cy="411480"/>
           </a:xfrm>
           <a:prstGeom prst="rect">
@@ -5148,16 +5211,40 @@
           </a:graphicData>
         </a:graphic>
       </p:graphicFrame>
-      <p:sp>
-        <p:nvSpPr>
-          <p:cNvPr id="9" name="TextBox 8"/>
+      <p:pic>
+        <p:nvPicPr>
+          <p:cNvPr id="9" name="Picture 8" descr="squirrel-cacao.png"/>
+          <p:cNvPicPr>
+            <a:picLocks noChangeAspect="1"/>
+          </p:cNvPicPr>
+          <p:nvPr/>
+        </p:nvPicPr>
+        <p:blipFill>
+          <a:blip r:embed="rId3"/>
+          <a:stretch>
+            <a:fillRect/>
+          </a:stretch>
+        </p:blipFill>
+        <p:spPr>
+          <a:xfrm>
+            <a:off x="411480" y="6382512"/>
+            <a:ext cx="308283" cy="292608"/>
+          </a:xfrm>
+          <a:prstGeom prst="rect">
+            <a:avLst/>
+          </a:prstGeom>
+        </p:spPr>
+      </p:pic>
+      <p:sp>
+        <p:nvSpPr>
+          <p:cNvPr id="10" name="TextBox 9"/>
           <p:cNvSpPr txBox="1"/>
           <p:nvPr/>
         </p:nvSpPr>
         <p:spPr>
           <a:xfrm>
-            <a:off x="502920" y="6446520"/>
-            <a:ext cx="8229600" cy="274320"/>
+            <a:off x="822960" y="6446520"/>
+            <a:ext cx="7772400" cy="274320"/>
           </a:xfrm>
           <a:prstGeom prst="rect">
             <a:avLst/>
@@ -5178,14 +5265,14 @@
                 </a:solidFill>
                 <a:latin typeface="Calibri"/>
               </a:rPr>
-              <a:t>La Querencia · FEAR 5 · V0→V3  ·  cacaocolab.org</a:t>
-            </a:r>
-          </a:p>
-        </p:txBody>
-      </p:sp>
-      <p:sp>
-        <p:nvSpPr>
-          <p:cNvPr id="10" name="TextBox 9"/>
+              <a:t>Cacao Colab  ·  La Querencia · FEAR 5 · V0→V3  ·  cacaocolab.org</a:t>
+            </a:r>
+          </a:p>
+        </p:txBody>
+      </p:sp>
+      <p:sp>
+        <p:nvSpPr>
+          <p:cNvPr id="11" name="TextBox 10"/>
           <p:cNvSpPr txBox="1"/>
           <p:nvPr/>
         </p:nvSpPr>
@@ -5245,7 +5332,7 @@
         <p:spPr>
           <a:xfrm>
             <a:off x="0" y="0"/>
-            <a:ext cx="12191695" cy="658368"/>
+            <a:ext cx="12191695" cy="777240"/>
           </a:xfrm>
           <a:prstGeom prst="rect">
             <a:avLst/>
@@ -5287,7 +5374,7 @@
         </p:nvSpPr>
         <p:spPr>
           <a:xfrm>
-            <a:off x="0" y="658368"/>
+            <a:off x="0" y="777240"/>
             <a:ext cx="12191695" cy="73152"/>
           </a:xfrm>
           <a:prstGeom prst="rect">
@@ -5322,16 +5409,40 @@
           </a:p>
         </p:txBody>
       </p:sp>
-      <p:sp>
-        <p:nvSpPr>
-          <p:cNvPr id="4" name="TextBox 3"/>
+      <p:pic>
+        <p:nvPicPr>
+          <p:cNvPr id="4" name="Picture 3" descr="lockup-yellow.png"/>
+          <p:cNvPicPr>
+            <a:picLocks noChangeAspect="1"/>
+          </p:cNvPicPr>
+          <p:nvPr/>
+        </p:nvPicPr>
+        <p:blipFill>
+          <a:blip r:embed="rId2"/>
+          <a:stretch>
+            <a:fillRect/>
+          </a:stretch>
+        </p:blipFill>
+        <p:spPr>
+          <a:xfrm>
+            <a:off x="365760" y="109728"/>
+            <a:ext cx="3741725" cy="566928"/>
+          </a:xfrm>
+          <a:prstGeom prst="rect">
+            <a:avLst/>
+          </a:prstGeom>
+        </p:spPr>
+      </p:pic>
+      <p:sp>
+        <p:nvSpPr>
+          <p:cNvPr id="5" name="TextBox 4"/>
           <p:cNvSpPr txBox="1"/>
           <p:nvPr/>
         </p:nvSpPr>
         <p:spPr>
           <a:xfrm>
-            <a:off x="502920" y="128016"/>
-            <a:ext cx="5486400" cy="411480"/>
+            <a:off x="6766560" y="256032"/>
+            <a:ext cx="5029200" cy="365760"/>
           </a:xfrm>
           <a:prstGeom prst="rect">
             <a:avLst/>
@@ -5344,41 +5455,6 @@
           </a:bodyPr>
           <a:lstStyle/>
           <a:p>
-            <a:pPr algn="l"/>
-            <a:r>
-              <a:rPr sz="2000" b="1">
-                <a:solidFill>
-                  <a:srgbClr val="F2C830"/>
-                </a:solidFill>
-                <a:latin typeface="Georgia"/>
-              </a:rPr>
-              <a:t>CACAO COLAB</a:t>
-            </a:r>
-          </a:p>
-        </p:txBody>
-      </p:sp>
-      <p:sp>
-        <p:nvSpPr>
-          <p:cNvPr id="5" name="TextBox 4"/>
-          <p:cNvSpPr txBox="1"/>
-          <p:nvPr/>
-        </p:nvSpPr>
-        <p:spPr>
-          <a:xfrm>
-            <a:off x="6217920" y="164592"/>
-            <a:ext cx="5394960" cy="365760"/>
-          </a:xfrm>
-          <a:prstGeom prst="rect">
-            <a:avLst/>
-          </a:prstGeom>
-          <a:noFill/>
-        </p:spPr>
-        <p:txBody>
-          <a:bodyPr wrap="square">
-            <a:spAutoFit/>
-          </a:bodyPr>
-          <a:lstStyle/>
-          <a:p>
             <a:pPr algn="r"/>
             <a:r>
               <a:rPr sz="1200" b="0">
@@ -5400,7 +5476,7 @@
         </p:nvSpPr>
         <p:spPr>
           <a:xfrm>
-            <a:off x="502920" y="960120"/>
+            <a:off x="502920" y="1051560"/>
             <a:ext cx="10972800" cy="411480"/>
           </a:xfrm>
           <a:prstGeom prst="rect">
@@ -6140,16 +6216,40 @@
           </a:graphicData>
         </a:graphic>
       </p:graphicFrame>
-      <p:sp>
-        <p:nvSpPr>
-          <p:cNvPr id="8" name="TextBox 7"/>
+      <p:pic>
+        <p:nvPicPr>
+          <p:cNvPr id="8" name="Picture 7" descr="squirrel-cacao.png"/>
+          <p:cNvPicPr>
+            <a:picLocks noChangeAspect="1"/>
+          </p:cNvPicPr>
+          <p:nvPr/>
+        </p:nvPicPr>
+        <p:blipFill>
+          <a:blip r:embed="rId3"/>
+          <a:stretch>
+            <a:fillRect/>
+          </a:stretch>
+        </p:blipFill>
+        <p:spPr>
+          <a:xfrm>
+            <a:off x="411480" y="6382512"/>
+            <a:ext cx="308283" cy="292608"/>
+          </a:xfrm>
+          <a:prstGeom prst="rect">
+            <a:avLst/>
+          </a:prstGeom>
+        </p:spPr>
+      </p:pic>
+      <p:sp>
+        <p:nvSpPr>
+          <p:cNvPr id="9" name="TextBox 8"/>
           <p:cNvSpPr txBox="1"/>
           <p:nvPr/>
         </p:nvSpPr>
         <p:spPr>
           <a:xfrm>
-            <a:off x="502920" y="6446520"/>
-            <a:ext cx="8229600" cy="274320"/>
+            <a:off x="822960" y="6446520"/>
+            <a:ext cx="7772400" cy="274320"/>
           </a:xfrm>
           <a:prstGeom prst="rect">
             <a:avLst/>
@@ -6170,14 +6270,14 @@
                 </a:solidFill>
                 <a:latin typeface="Calibri"/>
               </a:rPr>
-              <a:t>La Querencia · FEAR 5 · V0→V3  ·  cacaocolab.org</a:t>
-            </a:r>
-          </a:p>
-        </p:txBody>
-      </p:sp>
-      <p:sp>
-        <p:nvSpPr>
-          <p:cNvPr id="9" name="TextBox 8"/>
+              <a:t>Cacao Colab  ·  La Querencia · FEAR 5 · V0→V3  ·  cacaocolab.org</a:t>
+            </a:r>
+          </a:p>
+        </p:txBody>
+      </p:sp>
+      <p:sp>
+        <p:nvSpPr>
+          <p:cNvPr id="10" name="TextBox 9"/>
           <p:cNvSpPr txBox="1"/>
           <p:nvPr/>
         </p:nvSpPr>
@@ -6237,7 +6337,7 @@
         <p:spPr>
           <a:xfrm>
             <a:off x="0" y="0"/>
-            <a:ext cx="12191695" cy="658368"/>
+            <a:ext cx="12191695" cy="777240"/>
           </a:xfrm>
           <a:prstGeom prst="rect">
             <a:avLst/>
@@ -6279,7 +6379,7 @@
         </p:nvSpPr>
         <p:spPr>
           <a:xfrm>
-            <a:off x="0" y="658368"/>
+            <a:off x="0" y="777240"/>
             <a:ext cx="12191695" cy="73152"/>
           </a:xfrm>
           <a:prstGeom prst="rect">
@@ -6314,16 +6414,40 @@
           </a:p>
         </p:txBody>
       </p:sp>
-      <p:sp>
-        <p:nvSpPr>
-          <p:cNvPr id="4" name="TextBox 3"/>
+      <p:pic>
+        <p:nvPicPr>
+          <p:cNvPr id="4" name="Picture 3" descr="lockup-yellow.png"/>
+          <p:cNvPicPr>
+            <a:picLocks noChangeAspect="1"/>
+          </p:cNvPicPr>
+          <p:nvPr/>
+        </p:nvPicPr>
+        <p:blipFill>
+          <a:blip r:embed="rId2"/>
+          <a:stretch>
+            <a:fillRect/>
+          </a:stretch>
+        </p:blipFill>
+        <p:spPr>
+          <a:xfrm>
+            <a:off x="365760" y="109728"/>
+            <a:ext cx="3741725" cy="566928"/>
+          </a:xfrm>
+          <a:prstGeom prst="rect">
+            <a:avLst/>
+          </a:prstGeom>
+        </p:spPr>
+      </p:pic>
+      <p:sp>
+        <p:nvSpPr>
+          <p:cNvPr id="5" name="TextBox 4"/>
           <p:cNvSpPr txBox="1"/>
           <p:nvPr/>
         </p:nvSpPr>
         <p:spPr>
           <a:xfrm>
-            <a:off x="502920" y="128016"/>
-            <a:ext cx="5486400" cy="411480"/>
+            <a:off x="6766560" y="256032"/>
+            <a:ext cx="5029200" cy="365760"/>
           </a:xfrm>
           <a:prstGeom prst="rect">
             <a:avLst/>
@@ -6336,41 +6460,6 @@
           </a:bodyPr>
           <a:lstStyle/>
           <a:p>
-            <a:pPr algn="l"/>
-            <a:r>
-              <a:rPr sz="2000" b="1">
-                <a:solidFill>
-                  <a:srgbClr val="F2C830"/>
-                </a:solidFill>
-                <a:latin typeface="Georgia"/>
-              </a:rPr>
-              <a:t>CACAO COLAB</a:t>
-            </a:r>
-          </a:p>
-        </p:txBody>
-      </p:sp>
-      <p:sp>
-        <p:nvSpPr>
-          <p:cNvPr id="5" name="TextBox 4"/>
-          <p:cNvSpPr txBox="1"/>
-          <p:nvPr/>
-        </p:nvSpPr>
-        <p:spPr>
-          <a:xfrm>
-            <a:off x="6217920" y="164592"/>
-            <a:ext cx="5394960" cy="365760"/>
-          </a:xfrm>
-          <a:prstGeom prst="rect">
-            <a:avLst/>
-          </a:prstGeom>
-          <a:noFill/>
-        </p:spPr>
-        <p:txBody>
-          <a:bodyPr wrap="square">
-            <a:spAutoFit/>
-          </a:bodyPr>
-          <a:lstStyle/>
-          <a:p>
             <a:pPr algn="r"/>
             <a:r>
               <a:rPr sz="1200" b="0">
@@ -6392,7 +6481,7 @@
         </p:nvSpPr>
         <p:spPr>
           <a:xfrm>
-            <a:off x="502920" y="960120"/>
+            <a:off x="502920" y="1051560"/>
             <a:ext cx="10972800" cy="411480"/>
           </a:xfrm>
           <a:prstGeom prst="rect">
@@ -7092,16 +7181,40 @@
           </a:p>
         </p:txBody>
       </p:sp>
-      <p:sp>
-        <p:nvSpPr>
-          <p:cNvPr id="25" name="TextBox 24"/>
+      <p:pic>
+        <p:nvPicPr>
+          <p:cNvPr id="25" name="Picture 24" descr="squirrel-cacao.png"/>
+          <p:cNvPicPr>
+            <a:picLocks noChangeAspect="1"/>
+          </p:cNvPicPr>
+          <p:nvPr/>
+        </p:nvPicPr>
+        <p:blipFill>
+          <a:blip r:embed="rId3"/>
+          <a:stretch>
+            <a:fillRect/>
+          </a:stretch>
+        </p:blipFill>
+        <p:spPr>
+          <a:xfrm>
+            <a:off x="411480" y="6382512"/>
+            <a:ext cx="308283" cy="292608"/>
+          </a:xfrm>
+          <a:prstGeom prst="rect">
+            <a:avLst/>
+          </a:prstGeom>
+        </p:spPr>
+      </p:pic>
+      <p:sp>
+        <p:nvSpPr>
+          <p:cNvPr id="26" name="TextBox 25"/>
           <p:cNvSpPr txBox="1"/>
           <p:nvPr/>
         </p:nvSpPr>
         <p:spPr>
           <a:xfrm>
-            <a:off x="502920" y="6446520"/>
-            <a:ext cx="8229600" cy="274320"/>
+            <a:off x="822960" y="6446520"/>
+            <a:ext cx="7772400" cy="274320"/>
           </a:xfrm>
           <a:prstGeom prst="rect">
             <a:avLst/>
@@ -7122,14 +7235,14 @@
                 </a:solidFill>
                 <a:latin typeface="Calibri"/>
               </a:rPr>
-              <a:t>La Querencia · FEAR 5 · V0→V3  ·  cacaocolab.org</a:t>
-            </a:r>
-          </a:p>
-        </p:txBody>
-      </p:sp>
-      <p:sp>
-        <p:nvSpPr>
-          <p:cNvPr id="26" name="TextBox 25"/>
+              <a:t>Cacao Colab  ·  La Querencia · FEAR 5 · V0→V3  ·  cacaocolab.org</a:t>
+            </a:r>
+          </a:p>
+        </p:txBody>
+      </p:sp>
+      <p:sp>
+        <p:nvSpPr>
+          <p:cNvPr id="27" name="TextBox 26"/>
           <p:cNvSpPr txBox="1"/>
           <p:nvPr/>
         </p:nvSpPr>
@@ -7189,7 +7302,7 @@
         <p:spPr>
           <a:xfrm>
             <a:off x="0" y="0"/>
-            <a:ext cx="12191695" cy="658368"/>
+            <a:ext cx="12191695" cy="777240"/>
           </a:xfrm>
           <a:prstGeom prst="rect">
             <a:avLst/>
@@ -7231,7 +7344,7 @@
         </p:nvSpPr>
         <p:spPr>
           <a:xfrm>
-            <a:off x="0" y="658368"/>
+            <a:off x="0" y="777240"/>
             <a:ext cx="12191695" cy="73152"/>
           </a:xfrm>
           <a:prstGeom prst="rect">
@@ -7266,16 +7379,40 @@
           </a:p>
         </p:txBody>
       </p:sp>
-      <p:sp>
-        <p:nvSpPr>
-          <p:cNvPr id="4" name="TextBox 3"/>
+      <p:pic>
+        <p:nvPicPr>
+          <p:cNvPr id="4" name="Picture 3" descr="lockup-yellow.png"/>
+          <p:cNvPicPr>
+            <a:picLocks noChangeAspect="1"/>
+          </p:cNvPicPr>
+          <p:nvPr/>
+        </p:nvPicPr>
+        <p:blipFill>
+          <a:blip r:embed="rId2"/>
+          <a:stretch>
+            <a:fillRect/>
+          </a:stretch>
+        </p:blipFill>
+        <p:spPr>
+          <a:xfrm>
+            <a:off x="365760" y="109728"/>
+            <a:ext cx="3741725" cy="566928"/>
+          </a:xfrm>
+          <a:prstGeom prst="rect">
+            <a:avLst/>
+          </a:prstGeom>
+        </p:spPr>
+      </p:pic>
+      <p:sp>
+        <p:nvSpPr>
+          <p:cNvPr id="5" name="TextBox 4"/>
           <p:cNvSpPr txBox="1"/>
           <p:nvPr/>
         </p:nvSpPr>
         <p:spPr>
           <a:xfrm>
-            <a:off x="502920" y="128016"/>
-            <a:ext cx="5486400" cy="411480"/>
+            <a:off x="6766560" y="256032"/>
+            <a:ext cx="5029200" cy="365760"/>
           </a:xfrm>
           <a:prstGeom prst="rect">
             <a:avLst/>
@@ -7288,41 +7425,6 @@
           </a:bodyPr>
           <a:lstStyle/>
           <a:p>
-            <a:pPr algn="l"/>
-            <a:r>
-              <a:rPr sz="2000" b="1">
-                <a:solidFill>
-                  <a:srgbClr val="F2C830"/>
-                </a:solidFill>
-                <a:latin typeface="Georgia"/>
-              </a:rPr>
-              <a:t>CACAO COLAB</a:t>
-            </a:r>
-          </a:p>
-        </p:txBody>
-      </p:sp>
-      <p:sp>
-        <p:nvSpPr>
-          <p:cNvPr id="5" name="TextBox 4"/>
-          <p:cNvSpPr txBox="1"/>
-          <p:nvPr/>
-        </p:nvSpPr>
-        <p:spPr>
-          <a:xfrm>
-            <a:off x="6217920" y="164592"/>
-            <a:ext cx="5394960" cy="365760"/>
-          </a:xfrm>
-          <a:prstGeom prst="rect">
-            <a:avLst/>
-          </a:prstGeom>
-          <a:noFill/>
-        </p:spPr>
-        <p:txBody>
-          <a:bodyPr wrap="square">
-            <a:spAutoFit/>
-          </a:bodyPr>
-          <a:lstStyle/>
-          <a:p>
             <a:pPr algn="r"/>
             <a:r>
               <a:rPr sz="1200" b="0">
@@ -7344,7 +7446,7 @@
         </p:nvSpPr>
         <p:spPr>
           <a:xfrm>
-            <a:off x="502920" y="960120"/>
+            <a:off x="502920" y="1051560"/>
             <a:ext cx="10972800" cy="457200"/>
           </a:xfrm>
           <a:prstGeom prst="rect">
@@ -7527,16 +7629,40 @@
           </a:p>
         </p:txBody>
       </p:sp>
-      <p:sp>
-        <p:nvSpPr>
-          <p:cNvPr id="8" name="TextBox 7"/>
+      <p:pic>
+        <p:nvPicPr>
+          <p:cNvPr id="8" name="Picture 7" descr="squirrel-cacao.png"/>
+          <p:cNvPicPr>
+            <a:picLocks noChangeAspect="1"/>
+          </p:cNvPicPr>
+          <p:nvPr/>
+        </p:nvPicPr>
+        <p:blipFill>
+          <a:blip r:embed="rId3"/>
+          <a:stretch>
+            <a:fillRect/>
+          </a:stretch>
+        </p:blipFill>
+        <p:spPr>
+          <a:xfrm>
+            <a:off x="411480" y="6382512"/>
+            <a:ext cx="308283" cy="292608"/>
+          </a:xfrm>
+          <a:prstGeom prst="rect">
+            <a:avLst/>
+          </a:prstGeom>
+        </p:spPr>
+      </p:pic>
+      <p:sp>
+        <p:nvSpPr>
+          <p:cNvPr id="9" name="TextBox 8"/>
           <p:cNvSpPr txBox="1"/>
           <p:nvPr/>
         </p:nvSpPr>
         <p:spPr>
           <a:xfrm>
-            <a:off x="502920" y="6446520"/>
-            <a:ext cx="8229600" cy="274320"/>
+            <a:off x="822960" y="6446520"/>
+            <a:ext cx="7772400" cy="274320"/>
           </a:xfrm>
           <a:prstGeom prst="rect">
             <a:avLst/>
@@ -7557,14 +7683,14 @@
                 </a:solidFill>
                 <a:latin typeface="Calibri"/>
               </a:rPr>
-              <a:t>La Querencia · FEAR 5 · V0→V3  ·  cacaocolab.org</a:t>
-            </a:r>
-          </a:p>
-        </p:txBody>
-      </p:sp>
-      <p:sp>
-        <p:nvSpPr>
-          <p:cNvPr id="9" name="TextBox 8"/>
+              <a:t>Cacao Colab  ·  La Querencia · FEAR 5 · V0→V3  ·  cacaocolab.org</a:t>
+            </a:r>
+          </a:p>
+        </p:txBody>
+      </p:sp>
+      <p:sp>
+        <p:nvSpPr>
+          <p:cNvPr id="10" name="TextBox 9"/>
           <p:cNvSpPr txBox="1"/>
           <p:nvPr/>
         </p:nvSpPr>
@@ -7624,7 +7750,7 @@
         <p:spPr>
           <a:xfrm>
             <a:off x="0" y="0"/>
-            <a:ext cx="12191695" cy="658368"/>
+            <a:ext cx="12191695" cy="777240"/>
           </a:xfrm>
           <a:prstGeom prst="rect">
             <a:avLst/>
@@ -7666,7 +7792,7 @@
         </p:nvSpPr>
         <p:spPr>
           <a:xfrm>
-            <a:off x="0" y="658368"/>
+            <a:off x="0" y="777240"/>
             <a:ext cx="12191695" cy="73152"/>
           </a:xfrm>
           <a:prstGeom prst="rect">
@@ -7701,16 +7827,40 @@
           </a:p>
         </p:txBody>
       </p:sp>
-      <p:sp>
-        <p:nvSpPr>
-          <p:cNvPr id="4" name="TextBox 3"/>
+      <p:pic>
+        <p:nvPicPr>
+          <p:cNvPr id="4" name="Picture 3" descr="lockup-yellow.png"/>
+          <p:cNvPicPr>
+            <a:picLocks noChangeAspect="1"/>
+          </p:cNvPicPr>
+          <p:nvPr/>
+        </p:nvPicPr>
+        <p:blipFill>
+          <a:blip r:embed="rId2"/>
+          <a:stretch>
+            <a:fillRect/>
+          </a:stretch>
+        </p:blipFill>
+        <p:spPr>
+          <a:xfrm>
+            <a:off x="365760" y="109728"/>
+            <a:ext cx="3741725" cy="566928"/>
+          </a:xfrm>
+          <a:prstGeom prst="rect">
+            <a:avLst/>
+          </a:prstGeom>
+        </p:spPr>
+      </p:pic>
+      <p:sp>
+        <p:nvSpPr>
+          <p:cNvPr id="5" name="TextBox 4"/>
           <p:cNvSpPr txBox="1"/>
           <p:nvPr/>
         </p:nvSpPr>
         <p:spPr>
           <a:xfrm>
-            <a:off x="502920" y="128016"/>
-            <a:ext cx="5486400" cy="411480"/>
+            <a:off x="6766560" y="256032"/>
+            <a:ext cx="5029200" cy="365760"/>
           </a:xfrm>
           <a:prstGeom prst="rect">
             <a:avLst/>
@@ -7723,41 +7873,6 @@
           </a:bodyPr>
           <a:lstStyle/>
           <a:p>
-            <a:pPr algn="l"/>
-            <a:r>
-              <a:rPr sz="2000" b="1">
-                <a:solidFill>
-                  <a:srgbClr val="F2C830"/>
-                </a:solidFill>
-                <a:latin typeface="Georgia"/>
-              </a:rPr>
-              <a:t>CACAO COLAB</a:t>
-            </a:r>
-          </a:p>
-        </p:txBody>
-      </p:sp>
-      <p:sp>
-        <p:nvSpPr>
-          <p:cNvPr id="5" name="TextBox 4"/>
-          <p:cNvSpPr txBox="1"/>
-          <p:nvPr/>
-        </p:nvSpPr>
-        <p:spPr>
-          <a:xfrm>
-            <a:off x="6217920" y="164592"/>
-            <a:ext cx="5394960" cy="365760"/>
-          </a:xfrm>
-          <a:prstGeom prst="rect">
-            <a:avLst/>
-          </a:prstGeom>
-          <a:noFill/>
-        </p:spPr>
-        <p:txBody>
-          <a:bodyPr wrap="square">
-            <a:spAutoFit/>
-          </a:bodyPr>
-          <a:lstStyle/>
-          <a:p>
             <a:pPr algn="r"/>
             <a:r>
               <a:rPr sz="1200" b="0">
@@ -7779,7 +7894,7 @@
         </p:nvSpPr>
         <p:spPr>
           <a:xfrm>
-            <a:off x="502920" y="960120"/>
+            <a:off x="502920" y="1051560"/>
             <a:ext cx="10972800" cy="411480"/>
           </a:xfrm>
           <a:prstGeom prst="rect">
@@ -8453,16 +8568,40 @@
           </a:p>
         </p:txBody>
       </p:sp>
-      <p:sp>
-        <p:nvSpPr>
-          <p:cNvPr id="24" name="TextBox 23"/>
+      <p:pic>
+        <p:nvPicPr>
+          <p:cNvPr id="24" name="Picture 23" descr="squirrel-cacao.png"/>
+          <p:cNvPicPr>
+            <a:picLocks noChangeAspect="1"/>
+          </p:cNvPicPr>
+          <p:nvPr/>
+        </p:nvPicPr>
+        <p:blipFill>
+          <a:blip r:embed="rId3"/>
+          <a:stretch>
+            <a:fillRect/>
+          </a:stretch>
+        </p:blipFill>
+        <p:spPr>
+          <a:xfrm>
+            <a:off x="411480" y="6382512"/>
+            <a:ext cx="308283" cy="292608"/>
+          </a:xfrm>
+          <a:prstGeom prst="rect">
+            <a:avLst/>
+          </a:prstGeom>
+        </p:spPr>
+      </p:pic>
+      <p:sp>
+        <p:nvSpPr>
+          <p:cNvPr id="25" name="TextBox 24"/>
           <p:cNvSpPr txBox="1"/>
           <p:nvPr/>
         </p:nvSpPr>
         <p:spPr>
           <a:xfrm>
-            <a:off x="502920" y="6446520"/>
-            <a:ext cx="8229600" cy="274320"/>
+            <a:off x="822960" y="6446520"/>
+            <a:ext cx="7772400" cy="274320"/>
           </a:xfrm>
           <a:prstGeom prst="rect">
             <a:avLst/>
@@ -8483,14 +8622,14 @@
                 </a:solidFill>
                 <a:latin typeface="Calibri"/>
               </a:rPr>
-              <a:t>La Querencia · FEAR 5 · V0→V3  ·  cacaocolab.org</a:t>
-            </a:r>
-          </a:p>
-        </p:txBody>
-      </p:sp>
-      <p:sp>
-        <p:nvSpPr>
-          <p:cNvPr id="25" name="TextBox 24"/>
+              <a:t>Cacao Colab  ·  La Querencia · FEAR 5 · V0→V3  ·  cacaocolab.org</a:t>
+            </a:r>
+          </a:p>
+        </p:txBody>
+      </p:sp>
+      <p:sp>
+        <p:nvSpPr>
+          <p:cNvPr id="26" name="TextBox 25"/>
           <p:cNvSpPr txBox="1"/>
           <p:nvPr/>
         </p:nvSpPr>
@@ -8550,7 +8689,7 @@
         <p:spPr>
           <a:xfrm>
             <a:off x="0" y="0"/>
-            <a:ext cx="12191695" cy="658368"/>
+            <a:ext cx="12191695" cy="777240"/>
           </a:xfrm>
           <a:prstGeom prst="rect">
             <a:avLst/>
@@ -8592,7 +8731,7 @@
         </p:nvSpPr>
         <p:spPr>
           <a:xfrm>
-            <a:off x="0" y="658368"/>
+            <a:off x="0" y="777240"/>
             <a:ext cx="12191695" cy="73152"/>
           </a:xfrm>
           <a:prstGeom prst="rect">
@@ -8627,16 +8766,40 @@
           </a:p>
         </p:txBody>
       </p:sp>
-      <p:sp>
-        <p:nvSpPr>
-          <p:cNvPr id="4" name="TextBox 3"/>
+      <p:pic>
+        <p:nvPicPr>
+          <p:cNvPr id="4" name="Picture 3" descr="lockup-yellow.png"/>
+          <p:cNvPicPr>
+            <a:picLocks noChangeAspect="1"/>
+          </p:cNvPicPr>
+          <p:nvPr/>
+        </p:nvPicPr>
+        <p:blipFill>
+          <a:blip r:embed="rId2"/>
+          <a:stretch>
+            <a:fillRect/>
+          </a:stretch>
+        </p:blipFill>
+        <p:spPr>
+          <a:xfrm>
+            <a:off x="365760" y="109728"/>
+            <a:ext cx="3741725" cy="566928"/>
+          </a:xfrm>
+          <a:prstGeom prst="rect">
+            <a:avLst/>
+          </a:prstGeom>
+        </p:spPr>
+      </p:pic>
+      <p:sp>
+        <p:nvSpPr>
+          <p:cNvPr id="5" name="TextBox 4"/>
           <p:cNvSpPr txBox="1"/>
           <p:nvPr/>
         </p:nvSpPr>
         <p:spPr>
           <a:xfrm>
-            <a:off x="502920" y="128016"/>
-            <a:ext cx="5486400" cy="411480"/>
+            <a:off x="6766560" y="256032"/>
+            <a:ext cx="5029200" cy="365760"/>
           </a:xfrm>
           <a:prstGeom prst="rect">
             <a:avLst/>
@@ -8649,41 +8812,6 @@
           </a:bodyPr>
           <a:lstStyle/>
           <a:p>
-            <a:pPr algn="l"/>
-            <a:r>
-              <a:rPr sz="2000" b="1">
-                <a:solidFill>
-                  <a:srgbClr val="F2C830"/>
-                </a:solidFill>
-                <a:latin typeface="Georgia"/>
-              </a:rPr>
-              <a:t>CACAO COLAB</a:t>
-            </a:r>
-          </a:p>
-        </p:txBody>
-      </p:sp>
-      <p:sp>
-        <p:nvSpPr>
-          <p:cNvPr id="5" name="TextBox 4"/>
-          <p:cNvSpPr txBox="1"/>
-          <p:nvPr/>
-        </p:nvSpPr>
-        <p:spPr>
-          <a:xfrm>
-            <a:off x="6217920" y="164592"/>
-            <a:ext cx="5394960" cy="365760"/>
-          </a:xfrm>
-          <a:prstGeom prst="rect">
-            <a:avLst/>
-          </a:prstGeom>
-          <a:noFill/>
-        </p:spPr>
-        <p:txBody>
-          <a:bodyPr wrap="square">
-            <a:spAutoFit/>
-          </a:bodyPr>
-          <a:lstStyle/>
-          <a:p>
             <a:pPr algn="r"/>
             <a:r>
               <a:rPr sz="1200" b="0">
@@ -8705,7 +8833,7 @@
         </p:nvSpPr>
         <p:spPr>
           <a:xfrm>
-            <a:off x="502920" y="960120"/>
+            <a:off x="502920" y="1051560"/>
             <a:ext cx="10972800" cy="457200"/>
           </a:xfrm>
           <a:prstGeom prst="rect">
@@ -8931,16 +9059,40 @@
           </a:p>
         </p:txBody>
       </p:sp>
-      <p:sp>
-        <p:nvSpPr>
-          <p:cNvPr id="10" name="TextBox 9"/>
+      <p:pic>
+        <p:nvPicPr>
+          <p:cNvPr id="10" name="Picture 9" descr="squirrel-cacao.png"/>
+          <p:cNvPicPr>
+            <a:picLocks noChangeAspect="1"/>
+          </p:cNvPicPr>
+          <p:nvPr/>
+        </p:nvPicPr>
+        <p:blipFill>
+          <a:blip r:embed="rId3"/>
+          <a:stretch>
+            <a:fillRect/>
+          </a:stretch>
+        </p:blipFill>
+        <p:spPr>
+          <a:xfrm>
+            <a:off x="411480" y="6382512"/>
+            <a:ext cx="308283" cy="292608"/>
+          </a:xfrm>
+          <a:prstGeom prst="rect">
+            <a:avLst/>
+          </a:prstGeom>
+        </p:spPr>
+      </p:pic>
+      <p:sp>
+        <p:nvSpPr>
+          <p:cNvPr id="11" name="TextBox 10"/>
           <p:cNvSpPr txBox="1"/>
           <p:nvPr/>
         </p:nvSpPr>
         <p:spPr>
           <a:xfrm>
-            <a:off x="502920" y="6446520"/>
-            <a:ext cx="8229600" cy="274320"/>
+            <a:off x="822960" y="6446520"/>
+            <a:ext cx="7772400" cy="274320"/>
           </a:xfrm>
           <a:prstGeom prst="rect">
             <a:avLst/>
@@ -8961,14 +9113,14 @@
                 </a:solidFill>
                 <a:latin typeface="Calibri"/>
               </a:rPr>
-              <a:t>La Querencia · FEAR 5 · V0→V3  ·  cacaocolab.org</a:t>
-            </a:r>
-          </a:p>
-        </p:txBody>
-      </p:sp>
-      <p:sp>
-        <p:nvSpPr>
-          <p:cNvPr id="11" name="TextBox 10"/>
+              <a:t>Cacao Colab  ·  La Querencia · FEAR 5 · V0→V3  ·  cacaocolab.org</a:t>
+            </a:r>
+          </a:p>
+        </p:txBody>
+      </p:sp>
+      <p:sp>
+        <p:nvSpPr>
+          <p:cNvPr id="12" name="TextBox 11"/>
           <p:cNvSpPr txBox="1"/>
           <p:nvPr/>
         </p:nvSpPr>
@@ -9028,7 +9180,7 @@
         <p:spPr>
           <a:xfrm>
             <a:off x="0" y="0"/>
-            <a:ext cx="12191695" cy="658368"/>
+            <a:ext cx="12191695" cy="777240"/>
           </a:xfrm>
           <a:prstGeom prst="rect">
             <a:avLst/>
@@ -9070,7 +9222,7 @@
         </p:nvSpPr>
         <p:spPr>
           <a:xfrm>
-            <a:off x="0" y="658368"/>
+            <a:off x="0" y="777240"/>
             <a:ext cx="12191695" cy="73152"/>
           </a:xfrm>
           <a:prstGeom prst="rect">
@@ -9105,16 +9257,40 @@
           </a:p>
         </p:txBody>
       </p:sp>
-      <p:sp>
-        <p:nvSpPr>
-          <p:cNvPr id="4" name="TextBox 3"/>
+      <p:pic>
+        <p:nvPicPr>
+          <p:cNvPr id="4" name="Picture 3" descr="lockup-yellow.png"/>
+          <p:cNvPicPr>
+            <a:picLocks noChangeAspect="1"/>
+          </p:cNvPicPr>
+          <p:nvPr/>
+        </p:nvPicPr>
+        <p:blipFill>
+          <a:blip r:embed="rId2"/>
+          <a:stretch>
+            <a:fillRect/>
+          </a:stretch>
+        </p:blipFill>
+        <p:spPr>
+          <a:xfrm>
+            <a:off x="365760" y="109728"/>
+            <a:ext cx="3741725" cy="566928"/>
+          </a:xfrm>
+          <a:prstGeom prst="rect">
+            <a:avLst/>
+          </a:prstGeom>
+        </p:spPr>
+      </p:pic>
+      <p:sp>
+        <p:nvSpPr>
+          <p:cNvPr id="5" name="TextBox 4"/>
           <p:cNvSpPr txBox="1"/>
           <p:nvPr/>
         </p:nvSpPr>
         <p:spPr>
           <a:xfrm>
-            <a:off x="502920" y="128016"/>
-            <a:ext cx="5486400" cy="411480"/>
+            <a:off x="6766560" y="256032"/>
+            <a:ext cx="5029200" cy="365760"/>
           </a:xfrm>
           <a:prstGeom prst="rect">
             <a:avLst/>
@@ -9127,41 +9303,6 @@
           </a:bodyPr>
           <a:lstStyle/>
           <a:p>
-            <a:pPr algn="l"/>
-            <a:r>
-              <a:rPr sz="2000" b="1">
-                <a:solidFill>
-                  <a:srgbClr val="F2C830"/>
-                </a:solidFill>
-                <a:latin typeface="Georgia"/>
-              </a:rPr>
-              <a:t>CACAO COLAB</a:t>
-            </a:r>
-          </a:p>
-        </p:txBody>
-      </p:sp>
-      <p:sp>
-        <p:nvSpPr>
-          <p:cNvPr id="5" name="TextBox 4"/>
-          <p:cNvSpPr txBox="1"/>
-          <p:nvPr/>
-        </p:nvSpPr>
-        <p:spPr>
-          <a:xfrm>
-            <a:off x="6217920" y="164592"/>
-            <a:ext cx="5394960" cy="365760"/>
-          </a:xfrm>
-          <a:prstGeom prst="rect">
-            <a:avLst/>
-          </a:prstGeom>
-          <a:noFill/>
-        </p:spPr>
-        <p:txBody>
-          <a:bodyPr wrap="square">
-            <a:spAutoFit/>
-          </a:bodyPr>
-          <a:lstStyle/>
-          <a:p>
             <a:pPr algn="r"/>
             <a:r>
               <a:rPr sz="1200" b="0">
@@ -9183,7 +9324,7 @@
         </p:nvSpPr>
         <p:spPr>
           <a:xfrm>
-            <a:off x="502920" y="960120"/>
+            <a:off x="502920" y="1051560"/>
             <a:ext cx="10972800" cy="411480"/>
           </a:xfrm>
           <a:prstGeom prst="rect">
@@ -9720,16 +9861,40 @@
           </a:p>
         </p:txBody>
       </p:sp>
-      <p:sp>
-        <p:nvSpPr>
-          <p:cNvPr id="13" name="TextBox 12"/>
+      <p:pic>
+        <p:nvPicPr>
+          <p:cNvPr id="13" name="Picture 12" descr="squirrel-cacao.png"/>
+          <p:cNvPicPr>
+            <a:picLocks noChangeAspect="1"/>
+          </p:cNvPicPr>
+          <p:nvPr/>
+        </p:nvPicPr>
+        <p:blipFill>
+          <a:blip r:embed="rId3"/>
+          <a:stretch>
+            <a:fillRect/>
+          </a:stretch>
+        </p:blipFill>
+        <p:spPr>
+          <a:xfrm>
+            <a:off x="411480" y="6382512"/>
+            <a:ext cx="308283" cy="292608"/>
+          </a:xfrm>
+          <a:prstGeom prst="rect">
+            <a:avLst/>
+          </a:prstGeom>
+        </p:spPr>
+      </p:pic>
+      <p:sp>
+        <p:nvSpPr>
+          <p:cNvPr id="14" name="TextBox 13"/>
           <p:cNvSpPr txBox="1"/>
           <p:nvPr/>
         </p:nvSpPr>
         <p:spPr>
           <a:xfrm>
-            <a:off x="502920" y="6446520"/>
-            <a:ext cx="8229600" cy="274320"/>
+            <a:off x="822960" y="6446520"/>
+            <a:ext cx="7772400" cy="274320"/>
           </a:xfrm>
           <a:prstGeom prst="rect">
             <a:avLst/>
@@ -9750,14 +9915,14 @@
                 </a:solidFill>
                 <a:latin typeface="Calibri"/>
               </a:rPr>
-              <a:t>La Querencia · FEAR 5 · V0→V3  ·  cacaocolab.org</a:t>
-            </a:r>
-          </a:p>
-        </p:txBody>
-      </p:sp>
-      <p:sp>
-        <p:nvSpPr>
-          <p:cNvPr id="14" name="TextBox 13"/>
+              <a:t>Cacao Colab  ·  La Querencia · FEAR 5 · V0→V3  ·  cacaocolab.org</a:t>
+            </a:r>
+          </a:p>
+        </p:txBody>
+      </p:sp>
+      <p:sp>
+        <p:nvSpPr>
+          <p:cNvPr id="15" name="TextBox 14"/>
           <p:cNvSpPr txBox="1"/>
           <p:nvPr/>
         </p:nvSpPr>
@@ -9817,7 +9982,7 @@
         <p:spPr>
           <a:xfrm>
             <a:off x="0" y="0"/>
-            <a:ext cx="12191695" cy="658368"/>
+            <a:ext cx="12191695" cy="777240"/>
           </a:xfrm>
           <a:prstGeom prst="rect">
             <a:avLst/>
@@ -9859,7 +10024,7 @@
         </p:nvSpPr>
         <p:spPr>
           <a:xfrm>
-            <a:off x="0" y="658368"/>
+            <a:off x="0" y="777240"/>
             <a:ext cx="12191695" cy="73152"/>
           </a:xfrm>
           <a:prstGeom prst="rect">
@@ -9894,16 +10059,40 @@
           </a:p>
         </p:txBody>
       </p:sp>
-      <p:sp>
-        <p:nvSpPr>
-          <p:cNvPr id="4" name="TextBox 3"/>
+      <p:pic>
+        <p:nvPicPr>
+          <p:cNvPr id="4" name="Picture 3" descr="lockup-yellow.png"/>
+          <p:cNvPicPr>
+            <a:picLocks noChangeAspect="1"/>
+          </p:cNvPicPr>
+          <p:nvPr/>
+        </p:nvPicPr>
+        <p:blipFill>
+          <a:blip r:embed="rId2"/>
+          <a:stretch>
+            <a:fillRect/>
+          </a:stretch>
+        </p:blipFill>
+        <p:spPr>
+          <a:xfrm>
+            <a:off x="365760" y="109728"/>
+            <a:ext cx="3741725" cy="566928"/>
+          </a:xfrm>
+          <a:prstGeom prst="rect">
+            <a:avLst/>
+          </a:prstGeom>
+        </p:spPr>
+      </p:pic>
+      <p:sp>
+        <p:nvSpPr>
+          <p:cNvPr id="5" name="TextBox 4"/>
           <p:cNvSpPr txBox="1"/>
           <p:nvPr/>
         </p:nvSpPr>
         <p:spPr>
           <a:xfrm>
-            <a:off x="502920" y="128016"/>
-            <a:ext cx="5486400" cy="411480"/>
+            <a:off x="6766560" y="256032"/>
+            <a:ext cx="5029200" cy="365760"/>
           </a:xfrm>
           <a:prstGeom prst="rect">
             <a:avLst/>
@@ -9916,41 +10105,6 @@
           </a:bodyPr>
           <a:lstStyle/>
           <a:p>
-            <a:pPr algn="l"/>
-            <a:r>
-              <a:rPr sz="2000" b="1">
-                <a:solidFill>
-                  <a:srgbClr val="F2C830"/>
-                </a:solidFill>
-                <a:latin typeface="Georgia"/>
-              </a:rPr>
-              <a:t>CACAO COLAB</a:t>
-            </a:r>
-          </a:p>
-        </p:txBody>
-      </p:sp>
-      <p:sp>
-        <p:nvSpPr>
-          <p:cNvPr id="5" name="TextBox 4"/>
-          <p:cNvSpPr txBox="1"/>
-          <p:nvPr/>
-        </p:nvSpPr>
-        <p:spPr>
-          <a:xfrm>
-            <a:off x="6217920" y="164592"/>
-            <a:ext cx="5394960" cy="365760"/>
-          </a:xfrm>
-          <a:prstGeom prst="rect">
-            <a:avLst/>
-          </a:prstGeom>
-          <a:noFill/>
-        </p:spPr>
-        <p:txBody>
-          <a:bodyPr wrap="square">
-            <a:spAutoFit/>
-          </a:bodyPr>
-          <a:lstStyle/>
-          <a:p>
             <a:pPr algn="r"/>
             <a:r>
               <a:rPr sz="1200" b="0">
@@ -9972,7 +10126,7 @@
         </p:nvSpPr>
         <p:spPr>
           <a:xfrm>
-            <a:off x="502920" y="960120"/>
+            <a:off x="502920" y="1051560"/>
             <a:ext cx="10972800" cy="411480"/>
           </a:xfrm>
           <a:prstGeom prst="rect">
@@ -10433,16 +10587,40 @@
           </a:p>
         </p:txBody>
       </p:sp>
-      <p:sp>
-        <p:nvSpPr>
-          <p:cNvPr id="13" name="TextBox 12"/>
+      <p:pic>
+        <p:nvPicPr>
+          <p:cNvPr id="13" name="Picture 12" descr="squirrel-cacao.png"/>
+          <p:cNvPicPr>
+            <a:picLocks noChangeAspect="1"/>
+          </p:cNvPicPr>
+          <p:nvPr/>
+        </p:nvPicPr>
+        <p:blipFill>
+          <a:blip r:embed="rId3"/>
+          <a:stretch>
+            <a:fillRect/>
+          </a:stretch>
+        </p:blipFill>
+        <p:spPr>
+          <a:xfrm>
+            <a:off x="411480" y="6382512"/>
+            <a:ext cx="308283" cy="292608"/>
+          </a:xfrm>
+          <a:prstGeom prst="rect">
+            <a:avLst/>
+          </a:prstGeom>
+        </p:spPr>
+      </p:pic>
+      <p:sp>
+        <p:nvSpPr>
+          <p:cNvPr id="14" name="TextBox 13"/>
           <p:cNvSpPr txBox="1"/>
           <p:nvPr/>
         </p:nvSpPr>
         <p:spPr>
           <a:xfrm>
-            <a:off x="502920" y="6446520"/>
-            <a:ext cx="8229600" cy="274320"/>
+            <a:off x="822960" y="6446520"/>
+            <a:ext cx="7772400" cy="274320"/>
           </a:xfrm>
           <a:prstGeom prst="rect">
             <a:avLst/>
@@ -10463,14 +10641,14 @@
                 </a:solidFill>
                 <a:latin typeface="Calibri"/>
               </a:rPr>
-              <a:t>La Querencia · FEAR 5 · V0→V3  ·  cacaocolab.org</a:t>
-            </a:r>
-          </a:p>
-        </p:txBody>
-      </p:sp>
-      <p:sp>
-        <p:nvSpPr>
-          <p:cNvPr id="14" name="TextBox 13"/>
+              <a:t>Cacao Colab  ·  La Querencia · FEAR 5 · V0→V3  ·  cacaocolab.org</a:t>
+            </a:r>
+          </a:p>
+        </p:txBody>
+      </p:sp>
+      <p:sp>
+        <p:nvSpPr>
+          <p:cNvPr id="15" name="TextBox 14"/>
           <p:cNvSpPr txBox="1"/>
           <p:nvPr/>
         </p:nvSpPr>
@@ -10530,7 +10708,7 @@
         <p:spPr>
           <a:xfrm>
             <a:off x="0" y="0"/>
-            <a:ext cx="12191695" cy="658368"/>
+            <a:ext cx="12191695" cy="777240"/>
           </a:xfrm>
           <a:prstGeom prst="rect">
             <a:avLst/>
@@ -10572,7 +10750,7 @@
         </p:nvSpPr>
         <p:spPr>
           <a:xfrm>
-            <a:off x="0" y="658368"/>
+            <a:off x="0" y="777240"/>
             <a:ext cx="12191695" cy="73152"/>
           </a:xfrm>
           <a:prstGeom prst="rect">
@@ -10607,16 +10785,40 @@
           </a:p>
         </p:txBody>
       </p:sp>
-      <p:sp>
-        <p:nvSpPr>
-          <p:cNvPr id="4" name="TextBox 3"/>
+      <p:pic>
+        <p:nvPicPr>
+          <p:cNvPr id="4" name="Picture 3" descr="lockup-yellow.png"/>
+          <p:cNvPicPr>
+            <a:picLocks noChangeAspect="1"/>
+          </p:cNvPicPr>
+          <p:nvPr/>
+        </p:nvPicPr>
+        <p:blipFill>
+          <a:blip r:embed="rId2"/>
+          <a:stretch>
+            <a:fillRect/>
+          </a:stretch>
+        </p:blipFill>
+        <p:spPr>
+          <a:xfrm>
+            <a:off x="365760" y="109728"/>
+            <a:ext cx="3741725" cy="566928"/>
+          </a:xfrm>
+          <a:prstGeom prst="rect">
+            <a:avLst/>
+          </a:prstGeom>
+        </p:spPr>
+      </p:pic>
+      <p:sp>
+        <p:nvSpPr>
+          <p:cNvPr id="5" name="TextBox 4"/>
           <p:cNvSpPr txBox="1"/>
           <p:nvPr/>
         </p:nvSpPr>
         <p:spPr>
           <a:xfrm>
-            <a:off x="502920" y="128016"/>
-            <a:ext cx="5486400" cy="411480"/>
+            <a:off x="6766560" y="256032"/>
+            <a:ext cx="5029200" cy="365760"/>
           </a:xfrm>
           <a:prstGeom prst="rect">
             <a:avLst/>
@@ -10629,41 +10831,6 @@
           </a:bodyPr>
           <a:lstStyle/>
           <a:p>
-            <a:pPr algn="l"/>
-            <a:r>
-              <a:rPr sz="2000" b="1">
-                <a:solidFill>
-                  <a:srgbClr val="F2C830"/>
-                </a:solidFill>
-                <a:latin typeface="Georgia"/>
-              </a:rPr>
-              <a:t>CACAO COLAB</a:t>
-            </a:r>
-          </a:p>
-        </p:txBody>
-      </p:sp>
-      <p:sp>
-        <p:nvSpPr>
-          <p:cNvPr id="5" name="TextBox 4"/>
-          <p:cNvSpPr txBox="1"/>
-          <p:nvPr/>
-        </p:nvSpPr>
-        <p:spPr>
-          <a:xfrm>
-            <a:off x="6217920" y="164592"/>
-            <a:ext cx="5394960" cy="365760"/>
-          </a:xfrm>
-          <a:prstGeom prst="rect">
-            <a:avLst/>
-          </a:prstGeom>
-          <a:noFill/>
-        </p:spPr>
-        <p:txBody>
-          <a:bodyPr wrap="square">
-            <a:spAutoFit/>
-          </a:bodyPr>
-          <a:lstStyle/>
-          <a:p>
             <a:pPr algn="r"/>
             <a:r>
               <a:rPr sz="1200" b="0">
@@ -10685,7 +10852,7 @@
         </p:nvSpPr>
         <p:spPr>
           <a:xfrm>
-            <a:off x="502920" y="960120"/>
+            <a:off x="502920" y="1051560"/>
             <a:ext cx="10972800" cy="411480"/>
           </a:xfrm>
           <a:prstGeom prst="rect">
@@ -11600,16 +11767,40 @@
           </a:p>
         </p:txBody>
       </p:sp>
-      <p:sp>
-        <p:nvSpPr>
-          <p:cNvPr id="31" name="TextBox 30"/>
+      <p:pic>
+        <p:nvPicPr>
+          <p:cNvPr id="31" name="Picture 30" descr="squirrel-cacao.png"/>
+          <p:cNvPicPr>
+            <a:picLocks noChangeAspect="1"/>
+          </p:cNvPicPr>
+          <p:nvPr/>
+        </p:nvPicPr>
+        <p:blipFill>
+          <a:blip r:embed="rId3"/>
+          <a:stretch>
+            <a:fillRect/>
+          </a:stretch>
+        </p:blipFill>
+        <p:spPr>
+          <a:xfrm>
+            <a:off x="411480" y="6382512"/>
+            <a:ext cx="308283" cy="292608"/>
+          </a:xfrm>
+          <a:prstGeom prst="rect">
+            <a:avLst/>
+          </a:prstGeom>
+        </p:spPr>
+      </p:pic>
+      <p:sp>
+        <p:nvSpPr>
+          <p:cNvPr id="32" name="TextBox 31"/>
           <p:cNvSpPr txBox="1"/>
           <p:nvPr/>
         </p:nvSpPr>
         <p:spPr>
           <a:xfrm>
-            <a:off x="502920" y="6446520"/>
-            <a:ext cx="8229600" cy="274320"/>
+            <a:off x="822960" y="6446520"/>
+            <a:ext cx="7772400" cy="274320"/>
           </a:xfrm>
           <a:prstGeom prst="rect">
             <a:avLst/>
@@ -11630,14 +11821,14 @@
                 </a:solidFill>
                 <a:latin typeface="Calibri"/>
               </a:rPr>
-              <a:t>La Querencia · FEAR 5 · V0→V3  ·  cacaocolab.org</a:t>
-            </a:r>
-          </a:p>
-        </p:txBody>
-      </p:sp>
-      <p:sp>
-        <p:nvSpPr>
-          <p:cNvPr id="32" name="TextBox 31"/>
+              <a:t>Cacao Colab  ·  La Querencia · FEAR 5 · V0→V3  ·  cacaocolab.org</a:t>
+            </a:r>
+          </a:p>
+        </p:txBody>
+      </p:sp>
+      <p:sp>
+        <p:nvSpPr>
+          <p:cNvPr id="33" name="TextBox 32"/>
           <p:cNvSpPr txBox="1"/>
           <p:nvPr/>
         </p:nvSpPr>
@@ -11697,7 +11888,7 @@
         <p:spPr>
           <a:xfrm>
             <a:off x="0" y="0"/>
-            <a:ext cx="12191695" cy="658368"/>
+            <a:ext cx="12191695" cy="777240"/>
           </a:xfrm>
           <a:prstGeom prst="rect">
             <a:avLst/>
@@ -11739,7 +11930,7 @@
         </p:nvSpPr>
         <p:spPr>
           <a:xfrm>
-            <a:off x="0" y="658368"/>
+            <a:off x="0" y="777240"/>
             <a:ext cx="12191695" cy="73152"/>
           </a:xfrm>
           <a:prstGeom prst="rect">
@@ -11774,16 +11965,40 @@
           </a:p>
         </p:txBody>
       </p:sp>
-      <p:sp>
-        <p:nvSpPr>
-          <p:cNvPr id="4" name="TextBox 3"/>
+      <p:pic>
+        <p:nvPicPr>
+          <p:cNvPr id="4" name="Picture 3" descr="lockup-yellow.png"/>
+          <p:cNvPicPr>
+            <a:picLocks noChangeAspect="1"/>
+          </p:cNvPicPr>
+          <p:nvPr/>
+        </p:nvPicPr>
+        <p:blipFill>
+          <a:blip r:embed="rId2"/>
+          <a:stretch>
+            <a:fillRect/>
+          </a:stretch>
+        </p:blipFill>
+        <p:spPr>
+          <a:xfrm>
+            <a:off x="365760" y="109728"/>
+            <a:ext cx="3741725" cy="566928"/>
+          </a:xfrm>
+          <a:prstGeom prst="rect">
+            <a:avLst/>
+          </a:prstGeom>
+        </p:spPr>
+      </p:pic>
+      <p:sp>
+        <p:nvSpPr>
+          <p:cNvPr id="5" name="TextBox 4"/>
           <p:cNvSpPr txBox="1"/>
           <p:nvPr/>
         </p:nvSpPr>
         <p:spPr>
           <a:xfrm>
-            <a:off x="502920" y="128016"/>
-            <a:ext cx="5486400" cy="411480"/>
+            <a:off x="6766560" y="256032"/>
+            <a:ext cx="5029200" cy="365760"/>
           </a:xfrm>
           <a:prstGeom prst="rect">
             <a:avLst/>
@@ -11796,41 +12011,6 @@
           </a:bodyPr>
           <a:lstStyle/>
           <a:p>
-            <a:pPr algn="l"/>
-            <a:r>
-              <a:rPr sz="2000" b="1">
-                <a:solidFill>
-                  <a:srgbClr val="F2C830"/>
-                </a:solidFill>
-                <a:latin typeface="Georgia"/>
-              </a:rPr>
-              <a:t>CACAO COLAB</a:t>
-            </a:r>
-          </a:p>
-        </p:txBody>
-      </p:sp>
-      <p:sp>
-        <p:nvSpPr>
-          <p:cNvPr id="5" name="TextBox 4"/>
-          <p:cNvSpPr txBox="1"/>
-          <p:nvPr/>
-        </p:nvSpPr>
-        <p:spPr>
-          <a:xfrm>
-            <a:off x="6217920" y="164592"/>
-            <a:ext cx="5394960" cy="365760"/>
-          </a:xfrm>
-          <a:prstGeom prst="rect">
-            <a:avLst/>
-          </a:prstGeom>
-          <a:noFill/>
-        </p:spPr>
-        <p:txBody>
-          <a:bodyPr wrap="square">
-            <a:spAutoFit/>
-          </a:bodyPr>
-          <a:lstStyle/>
-          <a:p>
             <a:pPr algn="r"/>
             <a:r>
               <a:rPr sz="1200" b="0">
@@ -11852,7 +12032,7 @@
         </p:nvSpPr>
         <p:spPr>
           <a:xfrm>
-            <a:off x="502920" y="960120"/>
+            <a:off x="502920" y="1051560"/>
             <a:ext cx="10972800" cy="411480"/>
           </a:xfrm>
           <a:prstGeom prst="rect">
@@ -12097,16 +12277,40 @@
           </a:p>
         </p:txBody>
       </p:sp>
-      <p:sp>
-        <p:nvSpPr>
-          <p:cNvPr id="10" name="TextBox 9"/>
+      <p:pic>
+        <p:nvPicPr>
+          <p:cNvPr id="10" name="Picture 9" descr="squirrel-cacao.png"/>
+          <p:cNvPicPr>
+            <a:picLocks noChangeAspect="1"/>
+          </p:cNvPicPr>
+          <p:nvPr/>
+        </p:nvPicPr>
+        <p:blipFill>
+          <a:blip r:embed="rId3"/>
+          <a:stretch>
+            <a:fillRect/>
+          </a:stretch>
+        </p:blipFill>
+        <p:spPr>
+          <a:xfrm>
+            <a:off x="411480" y="6382512"/>
+            <a:ext cx="308283" cy="292608"/>
+          </a:xfrm>
+          <a:prstGeom prst="rect">
+            <a:avLst/>
+          </a:prstGeom>
+        </p:spPr>
+      </p:pic>
+      <p:sp>
+        <p:nvSpPr>
+          <p:cNvPr id="11" name="TextBox 10"/>
           <p:cNvSpPr txBox="1"/>
           <p:nvPr/>
         </p:nvSpPr>
         <p:spPr>
           <a:xfrm>
-            <a:off x="502920" y="6446520"/>
-            <a:ext cx="8229600" cy="274320"/>
+            <a:off x="822960" y="6446520"/>
+            <a:ext cx="7772400" cy="274320"/>
           </a:xfrm>
           <a:prstGeom prst="rect">
             <a:avLst/>
@@ -12127,14 +12331,14 @@
                 </a:solidFill>
                 <a:latin typeface="Calibri"/>
               </a:rPr>
-              <a:t>La Querencia · FEAR 5 · V0→V3  ·  cacaocolab.org</a:t>
-            </a:r>
-          </a:p>
-        </p:txBody>
-      </p:sp>
-      <p:sp>
-        <p:nvSpPr>
-          <p:cNvPr id="11" name="TextBox 10"/>
+              <a:t>Cacao Colab  ·  La Querencia · FEAR 5 · V0→V3  ·  cacaocolab.org</a:t>
+            </a:r>
+          </a:p>
+        </p:txBody>
+      </p:sp>
+      <p:sp>
+        <p:nvSpPr>
+          <p:cNvPr id="12" name="TextBox 11"/>
           <p:cNvSpPr txBox="1"/>
           <p:nvPr/>
         </p:nvSpPr>
@@ -12194,7 +12398,7 @@
         <p:spPr>
           <a:xfrm>
             <a:off x="0" y="0"/>
-            <a:ext cx="12191695" cy="658368"/>
+            <a:ext cx="12191695" cy="777240"/>
           </a:xfrm>
           <a:prstGeom prst="rect">
             <a:avLst/>
@@ -12236,7 +12440,7 @@
         </p:nvSpPr>
         <p:spPr>
           <a:xfrm>
-            <a:off x="0" y="658368"/>
+            <a:off x="0" y="777240"/>
             <a:ext cx="12191695" cy="73152"/>
           </a:xfrm>
           <a:prstGeom prst="rect">
@@ -12271,16 +12475,40 @@
           </a:p>
         </p:txBody>
       </p:sp>
-      <p:sp>
-        <p:nvSpPr>
-          <p:cNvPr id="4" name="TextBox 3"/>
+      <p:pic>
+        <p:nvPicPr>
+          <p:cNvPr id="4" name="Picture 3" descr="lockup-yellow.png"/>
+          <p:cNvPicPr>
+            <a:picLocks noChangeAspect="1"/>
+          </p:cNvPicPr>
+          <p:nvPr/>
+        </p:nvPicPr>
+        <p:blipFill>
+          <a:blip r:embed="rId2"/>
+          <a:stretch>
+            <a:fillRect/>
+          </a:stretch>
+        </p:blipFill>
+        <p:spPr>
+          <a:xfrm>
+            <a:off x="365760" y="109728"/>
+            <a:ext cx="3741725" cy="566928"/>
+          </a:xfrm>
+          <a:prstGeom prst="rect">
+            <a:avLst/>
+          </a:prstGeom>
+        </p:spPr>
+      </p:pic>
+      <p:sp>
+        <p:nvSpPr>
+          <p:cNvPr id="5" name="TextBox 4"/>
           <p:cNvSpPr txBox="1"/>
           <p:nvPr/>
         </p:nvSpPr>
         <p:spPr>
           <a:xfrm>
-            <a:off x="502920" y="128016"/>
-            <a:ext cx="5486400" cy="411480"/>
+            <a:off x="6766560" y="256032"/>
+            <a:ext cx="5029200" cy="365760"/>
           </a:xfrm>
           <a:prstGeom prst="rect">
             <a:avLst/>
@@ -12293,41 +12521,6 @@
           </a:bodyPr>
           <a:lstStyle/>
           <a:p>
-            <a:pPr algn="l"/>
-            <a:r>
-              <a:rPr sz="2000" b="1">
-                <a:solidFill>
-                  <a:srgbClr val="F2C830"/>
-                </a:solidFill>
-                <a:latin typeface="Georgia"/>
-              </a:rPr>
-              <a:t>CACAO COLAB</a:t>
-            </a:r>
-          </a:p>
-        </p:txBody>
-      </p:sp>
-      <p:sp>
-        <p:nvSpPr>
-          <p:cNvPr id="5" name="TextBox 4"/>
-          <p:cNvSpPr txBox="1"/>
-          <p:nvPr/>
-        </p:nvSpPr>
-        <p:spPr>
-          <a:xfrm>
-            <a:off x="6217920" y="164592"/>
-            <a:ext cx="5394960" cy="365760"/>
-          </a:xfrm>
-          <a:prstGeom prst="rect">
-            <a:avLst/>
-          </a:prstGeom>
-          <a:noFill/>
-        </p:spPr>
-        <p:txBody>
-          <a:bodyPr wrap="square">
-            <a:spAutoFit/>
-          </a:bodyPr>
-          <a:lstStyle/>
-          <a:p>
             <a:pPr algn="r"/>
             <a:r>
               <a:rPr sz="1200" b="0">
@@ -12349,7 +12542,7 @@
         </p:nvSpPr>
         <p:spPr>
           <a:xfrm>
-            <a:off x="502920" y="960120"/>
+            <a:off x="502920" y="1051560"/>
             <a:ext cx="10972800" cy="411480"/>
           </a:xfrm>
           <a:prstGeom prst="rect">
@@ -13264,16 +13457,40 @@
           </a:p>
         </p:txBody>
       </p:sp>
-      <p:sp>
-        <p:nvSpPr>
-          <p:cNvPr id="31" name="TextBox 30"/>
+      <p:pic>
+        <p:nvPicPr>
+          <p:cNvPr id="31" name="Picture 30" descr="squirrel-cacao.png"/>
+          <p:cNvPicPr>
+            <a:picLocks noChangeAspect="1"/>
+          </p:cNvPicPr>
+          <p:nvPr/>
+        </p:nvPicPr>
+        <p:blipFill>
+          <a:blip r:embed="rId3"/>
+          <a:stretch>
+            <a:fillRect/>
+          </a:stretch>
+        </p:blipFill>
+        <p:spPr>
+          <a:xfrm>
+            <a:off x="411480" y="6382512"/>
+            <a:ext cx="308283" cy="292608"/>
+          </a:xfrm>
+          <a:prstGeom prst="rect">
+            <a:avLst/>
+          </a:prstGeom>
+        </p:spPr>
+      </p:pic>
+      <p:sp>
+        <p:nvSpPr>
+          <p:cNvPr id="32" name="TextBox 31"/>
           <p:cNvSpPr txBox="1"/>
           <p:nvPr/>
         </p:nvSpPr>
         <p:spPr>
           <a:xfrm>
-            <a:off x="502920" y="6446520"/>
-            <a:ext cx="8229600" cy="274320"/>
+            <a:off x="822960" y="6446520"/>
+            <a:ext cx="7772400" cy="274320"/>
           </a:xfrm>
           <a:prstGeom prst="rect">
             <a:avLst/>
@@ -13294,14 +13511,14 @@
                 </a:solidFill>
                 <a:latin typeface="Calibri"/>
               </a:rPr>
-              <a:t>La Querencia · FEAR 5 · V0→V3  ·  cacaocolab.org</a:t>
-            </a:r>
-          </a:p>
-        </p:txBody>
-      </p:sp>
-      <p:sp>
-        <p:nvSpPr>
-          <p:cNvPr id="32" name="TextBox 31"/>
+              <a:t>Cacao Colab  ·  La Querencia · FEAR 5 · V0→V3  ·  cacaocolab.org</a:t>
+            </a:r>
+          </a:p>
+        </p:txBody>
+      </p:sp>
+      <p:sp>
+        <p:nvSpPr>
+          <p:cNvPr id="33" name="TextBox 32"/>
           <p:cNvSpPr txBox="1"/>
           <p:nvPr/>
         </p:nvSpPr>

</xml_diff>